<commit_message>
Added additional example for pandas usage in GFF files
</commit_message>
<xml_diff>
--- a/day4/Intro_to_Pandas_Matplotlib.pptx
+++ b/day4/Intro_to_Pandas_Matplotlib.pptx
@@ -276,7 +276,7 @@
           <a:p>
             <a:fld id="{804D97D1-C391-6F49-B5AF-97C34C6DCB2D}" type="datetimeFigureOut">
               <a:rPr lang="en-US" smtClean="0"/>
-              <a:t>3/23/26</a:t>
+              <a:t>7/7/26</a:t>
             </a:fld>
             <a:endParaRPr lang="en-US"/>
           </a:p>
@@ -474,7 +474,7 @@
           <a:p>
             <a:fld id="{804D97D1-C391-6F49-B5AF-97C34C6DCB2D}" type="datetimeFigureOut">
               <a:rPr lang="en-US" smtClean="0"/>
-              <a:t>3/23/26</a:t>
+              <a:t>7/7/26</a:t>
             </a:fld>
             <a:endParaRPr lang="en-US"/>
           </a:p>
@@ -682,7 +682,7 @@
           <a:p>
             <a:fld id="{804D97D1-C391-6F49-B5AF-97C34C6DCB2D}" type="datetimeFigureOut">
               <a:rPr lang="en-US" smtClean="0"/>
-              <a:t>3/23/26</a:t>
+              <a:t>7/7/26</a:t>
             </a:fld>
             <a:endParaRPr lang="en-US"/>
           </a:p>
@@ -880,7 +880,7 @@
           <a:p>
             <a:fld id="{804D97D1-C391-6F49-B5AF-97C34C6DCB2D}" type="datetimeFigureOut">
               <a:rPr lang="en-US" smtClean="0"/>
-              <a:t>3/23/26</a:t>
+              <a:t>7/7/26</a:t>
             </a:fld>
             <a:endParaRPr lang="en-US"/>
           </a:p>
@@ -1155,7 +1155,7 @@
           <a:p>
             <a:fld id="{804D97D1-C391-6F49-B5AF-97C34C6DCB2D}" type="datetimeFigureOut">
               <a:rPr lang="en-US" smtClean="0"/>
-              <a:t>3/23/26</a:t>
+              <a:t>7/7/26</a:t>
             </a:fld>
             <a:endParaRPr lang="en-US"/>
           </a:p>
@@ -1420,7 +1420,7 @@
           <a:p>
             <a:fld id="{804D97D1-C391-6F49-B5AF-97C34C6DCB2D}" type="datetimeFigureOut">
               <a:rPr lang="en-US" smtClean="0"/>
-              <a:t>3/23/26</a:t>
+              <a:t>7/7/26</a:t>
             </a:fld>
             <a:endParaRPr lang="en-US"/>
           </a:p>
@@ -1832,7 +1832,7 @@
           <a:p>
             <a:fld id="{804D97D1-C391-6F49-B5AF-97C34C6DCB2D}" type="datetimeFigureOut">
               <a:rPr lang="en-US" smtClean="0"/>
-              <a:t>3/23/26</a:t>
+              <a:t>7/7/26</a:t>
             </a:fld>
             <a:endParaRPr lang="en-US"/>
           </a:p>
@@ -1973,7 +1973,7 @@
           <a:p>
             <a:fld id="{804D97D1-C391-6F49-B5AF-97C34C6DCB2D}" type="datetimeFigureOut">
               <a:rPr lang="en-US" smtClean="0"/>
-              <a:t>3/23/26</a:t>
+              <a:t>7/7/26</a:t>
             </a:fld>
             <a:endParaRPr lang="en-US"/>
           </a:p>
@@ -2086,7 +2086,7 @@
           <a:p>
             <a:fld id="{804D97D1-C391-6F49-B5AF-97C34C6DCB2D}" type="datetimeFigureOut">
               <a:rPr lang="en-US" smtClean="0"/>
-              <a:t>3/23/26</a:t>
+              <a:t>7/7/26</a:t>
             </a:fld>
             <a:endParaRPr lang="en-US"/>
           </a:p>
@@ -2397,7 +2397,7 @@
           <a:p>
             <a:fld id="{804D97D1-C391-6F49-B5AF-97C34C6DCB2D}" type="datetimeFigureOut">
               <a:rPr lang="en-US" smtClean="0"/>
-              <a:t>3/23/26</a:t>
+              <a:t>7/7/26</a:t>
             </a:fld>
             <a:endParaRPr lang="en-US"/>
           </a:p>
@@ -2685,7 +2685,7 @@
           <a:p>
             <a:fld id="{804D97D1-C391-6F49-B5AF-97C34C6DCB2D}" type="datetimeFigureOut">
               <a:rPr lang="en-US" smtClean="0"/>
-              <a:t>3/23/26</a:t>
+              <a:t>7/7/26</a:t>
             </a:fld>
             <a:endParaRPr lang="en-US"/>
           </a:p>
@@ -2926,7 +2926,7 @@
           <a:p>
             <a:fld id="{804D97D1-C391-6F49-B5AF-97C34C6DCB2D}" type="datetimeFigureOut">
               <a:rPr lang="en-US" smtClean="0"/>
-              <a:t>3/23/26</a:t>
+              <a:t>7/7/26</a:t>
             </a:fld>
             <a:endParaRPr lang="en-US"/>
           </a:p>
@@ -3404,9 +3404,10 @@
           </a:p>
           <a:p>
             <a:r>
-              <a:rPr lang="en-US" dirty="0"/>
-              <a:t>Day 3</a:t>
-            </a:r>
+              <a:rPr lang="en-US"/>
+              <a:t>Day 4</a:t>
+            </a:r>
+            <a:endParaRPr lang="en-US" dirty="0"/>
           </a:p>
         </p:txBody>
       </p:sp>

</xml_diff>